<commit_message>
Export deck to PDF for the lablab form; refresh test count and evidence bullet
Co-Authored-By: Claude Sonnet 5.5 <noreply@anthropic.com>
</commit_message>
<xml_diff>
--- a/docs/Second-Voice-deck.pptx
+++ b/docs/Second-Voice-deck.pptx
@@ -7319,7 +7319,7 @@
                 </a:solidFill>
                 <a:latin typeface="Calibri"/>
               </a:rPr>
-              <a:t>447</a:t>
+              <a:t>455</a:t>
             </a:r>
           </a:p>
         </p:txBody>
@@ -7811,7 +7811,7 @@
                 </a:solidFill>
                 <a:latin typeface="Calibri"/>
               </a:rPr>
-              <a:t>•  Still to do: real human voices and a real phone on speakerphone</a:t>
+              <a:t>•  Measured with a real phone: caught at conversational volume, within arm’s reach. Still to do: a range study and a bank pilot</a:t>
             </a:r>
           </a:p>
         </p:txBody>

</xml_diff>